<commit_message>
Architectural and Benchmarking documentation
</commit_message>
<xml_diff>
--- a/CentRI_5_minute_presentation.pptx
+++ b/CentRI_5_minute_presentation.pptx
@@ -930,7 +930,7 @@
           <a:lstStyle/>
           <a:p>
             <a:r>
-              <a:t>Position CentRI as composition, not replacement. Jev-like typed decisions can be an excellent stage-two selector, but a very large catalog still needs candidate discovery.</a:t>
+              <a:t>Position CentRI as a routing control plane. The important distinction is discovery versus choice: the local routing memory discovers candidates, while GPU-backed Nemotron resolves only the small candidate set.</a:t>
             </a:r>
           </a:p>
         </p:txBody>
@@ -12709,7 +12709,7 @@
               </a:defRPr>
             </a:pPr>
             <a:r>
-              <a:t>Jev-style choice</a:t>
+              <a:t>Flat choice surface</a:t>
             </a:r>
           </a:p>
         </p:txBody>
@@ -13976,7 +13976,7 @@
               </a:defRPr>
             </a:pPr>
             <a:r>
-              <a:t>Jev-style choice</a:t>
+              <a:t>Flat choice surface</a:t>
             </a:r>
           </a:p>
         </p:txBody>
@@ -14015,7 +14015,7 @@
               </a:defRPr>
             </a:pPr>
             <a:r>
-              <a:t>Typed, parallel bounded decisions</a:t>
+              <a:t>Fast bounded decisions</a:t>
             </a:r>
           </a:p>
         </p:txBody>
@@ -14054,7 +14054,7 @@
               </a:defRPr>
             </a:pPr>
             <a:r>
-              <a:t>Choice surface is enumerated; public interface documents ≤255 options</a:t>
+              <a:t>Full catalog must be serialized and maintained</a:t>
             </a:r>
           </a:p>
         </p:txBody>
@@ -14093,7 +14093,7 @@
               </a:defRPr>
             </a:pPr>
             <a:r>
-              <a:t>Use candidate discovery before typed choice when A is large</a:t>
+              <a:t>Discover candidates locally before bounded GPU reasoning</a:t>
             </a:r>
           </a:p>
         </p:txBody>
@@ -14495,7 +14495,7 @@
               </a:defRPr>
             </a:pPr>
             <a:r>
-              <a:t>Jev architecture reference: jevtypesafeai.com/jev/architecture</a:t>
+              <a:t>Scale principle: local discovery keeps GPU decision context bounded</a:t>
             </a:r>
           </a:p>
         </p:txBody>
@@ -16492,7 +16492,7 @@
               </a:defRPr>
             </a:pPr>
             <a:r>
-              <a:t>Jev public architecture</a:t>
+              <a:t>CentRI benchmark report</a:t>
             </a:r>
           </a:p>
           <a:p>
@@ -16508,7 +16508,7 @@
               </a:defRPr>
             </a:pPr>
             <a:r>
-              <a:t>https://www.jevtypesafeai.com/jev/architecture</a:t>
+              <a:t> docs/benchmark_report.md</a:t>
             </a:r>
           </a:p>
         </p:txBody>

</xml_diff>